<commit_message>
docs: update pitch deck with latest slides
Co-Authored-By: Claude Opus 4.8 <noreply@anthropic.com>
</commit_message>
<xml_diff>
--- a/docs/pitch/riskmesh-agent-risk-exchange.pptx
+++ b/docs/pitch/riskmesh-agent-risk-exchange.pptx
@@ -1491,6 +1491,10 @@
             <a:prstDash val="solid"/>
           </a:ln>
         </p:spPr>
+        <p:txBody xmlns:a="http://schemas.openxmlformats.org/drawingml/2006/main">
+          <a:bodyPr/>
+          <a:p/>
+        </p:txBody>
       </p:sp>
       <p:sp>
         <p:nvSpPr>
@@ -1520,7 +1524,7 @@
           <a:lstStyle xmlns:a="http://schemas.openxmlformats.org/drawingml/2006/main"/>
           <a:p xmlns:a="http://schemas.openxmlformats.org/drawingml/2006/main">
             <a:pPr algn="l">
-              <a:defRPr sz="900" b="1">
+              <a:defRPr sz="1150" b="1">
                 <a:solidFill>
                   <a:srgbClr val="4DF0C0"/>
                 </a:solidFill>
@@ -1569,6 +1573,10 @@
             <a:prstDash val="solid"/>
           </a:ln>
         </p:spPr>
+        <p:txBody xmlns:a="http://schemas.openxmlformats.org/drawingml/2006/main">
+          <a:bodyPr/>
+          <a:p/>
+        </p:txBody>
       </p:sp>
       <p:sp>
         <p:nvSpPr>
@@ -1602,6 +1610,10 @@
             <a:prstDash val="solid"/>
           </a:ln>
         </p:spPr>
+        <p:txBody xmlns:a="http://schemas.openxmlformats.org/drawingml/2006/main">
+          <a:bodyPr/>
+          <a:p/>
+        </p:txBody>
       </p:sp>
       <p:sp>
         <p:nvSpPr>
@@ -1674,7 +1686,7 @@
           <a:lstStyle xmlns:a="http://schemas.openxmlformats.org/drawingml/2006/main"/>
           <a:p xmlns:a="http://schemas.openxmlformats.org/drawingml/2006/main">
             <a:pPr algn="ctr">
-              <a:defRPr sz="1050" b="1">
+              <a:defRPr sz="1350" b="1">
                 <a:solidFill>
                   <a:srgbClr val="4DF0C0"/>
                 </a:solidFill>
@@ -1721,6 +1733,10 @@
             <a:prstDash val="solid"/>
           </a:ln>
         </p:spPr>
+        <p:txBody xmlns:a="http://schemas.openxmlformats.org/drawingml/2006/main">
+          <a:bodyPr/>
+          <a:p/>
+        </p:txBody>
       </p:sp>
       <p:sp>
         <p:nvSpPr>
@@ -1750,7 +1766,7 @@
           <a:lstStyle xmlns:a="http://schemas.openxmlformats.org/drawingml/2006/main"/>
           <a:p xmlns:a="http://schemas.openxmlformats.org/drawingml/2006/main">
             <a:pPr algn="ctr">
-              <a:defRPr sz="900" b="1">
+              <a:defRPr sz="1150" b="1">
                 <a:solidFill>
                   <a:srgbClr val="07111F"/>
                 </a:solidFill>
@@ -1797,6 +1813,10 @@
             <a:prstDash val="solid"/>
           </a:ln>
         </p:spPr>
+        <p:txBody xmlns:a="http://schemas.openxmlformats.org/drawingml/2006/main">
+          <a:bodyPr/>
+          <a:p/>
+        </p:txBody>
       </p:sp>
       <p:sp>
         <p:nvSpPr>
@@ -1826,7 +1846,7 @@
           <a:lstStyle xmlns:a="http://schemas.openxmlformats.org/drawingml/2006/main"/>
           <a:p xmlns:a="http://schemas.openxmlformats.org/drawingml/2006/main">
             <a:pPr algn="ctr">
-              <a:defRPr sz="900" b="1">
+              <a:defRPr sz="1150" b="1">
                 <a:solidFill>
                   <a:srgbClr val="07111F"/>
                 </a:solidFill>
@@ -1873,6 +1893,10 @@
             <a:prstDash val="solid"/>
           </a:ln>
         </p:spPr>
+        <p:txBody xmlns:a="http://schemas.openxmlformats.org/drawingml/2006/main">
+          <a:bodyPr/>
+          <a:p/>
+        </p:txBody>
       </p:sp>
       <p:sp>
         <p:nvSpPr>
@@ -1902,7 +1926,7 @@
           <a:lstStyle xmlns:a="http://schemas.openxmlformats.org/drawingml/2006/main"/>
           <a:p xmlns:a="http://schemas.openxmlformats.org/drawingml/2006/main">
             <a:pPr algn="ctr">
-              <a:defRPr sz="900" b="1">
+              <a:defRPr sz="1150" b="1">
                 <a:solidFill>
                   <a:srgbClr val="07111F"/>
                 </a:solidFill>
@@ -1949,6 +1973,10 @@
             <a:prstDash val="solid"/>
           </a:ln>
         </p:spPr>
+        <p:txBody xmlns:a="http://schemas.openxmlformats.org/drawingml/2006/main">
+          <a:bodyPr/>
+          <a:p/>
+        </p:txBody>
       </p:sp>
       <p:sp>
         <p:nvSpPr>
@@ -1978,7 +2006,7 @@
           <a:lstStyle xmlns:a="http://schemas.openxmlformats.org/drawingml/2006/main"/>
           <a:p xmlns:a="http://schemas.openxmlformats.org/drawingml/2006/main">
             <a:pPr algn="ctr">
-              <a:defRPr sz="900" b="1">
+              <a:defRPr sz="1150" b="1">
                 <a:solidFill>
                   <a:srgbClr val="07111F"/>
                 </a:solidFill>
@@ -2025,6 +2053,10 @@
             <a:prstDash val="solid"/>
           </a:ln>
         </p:spPr>
+        <p:txBody xmlns:a="http://schemas.openxmlformats.org/drawingml/2006/main">
+          <a:bodyPr/>
+          <a:p/>
+        </p:txBody>
       </p:sp>
       <p:sp>
         <p:nvSpPr>
@@ -2054,7 +2086,7 @@
           <a:lstStyle xmlns:a="http://schemas.openxmlformats.org/drawingml/2006/main"/>
           <a:p xmlns:a="http://schemas.openxmlformats.org/drawingml/2006/main">
             <a:pPr algn="ctr">
-              <a:defRPr sz="900" b="1">
+              <a:defRPr sz="1150" b="1">
                 <a:solidFill>
                   <a:srgbClr val="07111F"/>
                 </a:solidFill>
@@ -2140,7 +2172,7 @@
           <a:lstStyle xmlns:a="http://schemas.openxmlformats.org/drawingml/2006/main"/>
           <a:p xmlns:a="http://schemas.openxmlformats.org/drawingml/2006/main">
             <a:pPr algn="l">
-              <a:defRPr sz="1725" b="0">
+              <a:defRPr sz="1850" b="0">
                 <a:solidFill>
                   <a:srgbClr val="90A2BA"/>
                 </a:solidFill>
@@ -2183,7 +2215,7 @@
           <a:lstStyle xmlns:a="http://schemas.openxmlformats.org/drawingml/2006/main"/>
           <a:p xmlns:a="http://schemas.openxmlformats.org/drawingml/2006/main">
             <a:pPr algn="l">
-              <a:defRPr sz="2550" b="1">
+              <a:defRPr sz="2800" b="1">
                 <a:solidFill>
                   <a:srgbClr val="4DF0C0"/>
                 </a:solidFill>
@@ -2226,7 +2258,7 @@
           <a:lstStyle xmlns:a="http://schemas.openxmlformats.org/drawingml/2006/main"/>
           <a:p xmlns:a="http://schemas.openxmlformats.org/drawingml/2006/main">
             <a:pPr algn="l">
-              <a:defRPr sz="1050" b="1">
+              <a:defRPr sz="1350" b="1">
                 <a:solidFill>
                   <a:srgbClr val="F4F8FF"/>
                 </a:solidFill>
@@ -2269,7 +2301,7 @@
           <a:lstStyle xmlns:a="http://schemas.openxmlformats.org/drawingml/2006/main"/>
           <a:p xmlns:a="http://schemas.openxmlformats.org/drawingml/2006/main">
             <a:pPr algn="l">
-              <a:defRPr sz="750" b="0">
+              <a:defRPr sz="925" b="0">
                 <a:solidFill>
                   <a:srgbClr val="607792"/>
                 </a:solidFill>
@@ -2312,7 +2344,7 @@
           <a:lstStyle xmlns:a="http://schemas.openxmlformats.org/drawingml/2006/main"/>
           <a:p xmlns:a="http://schemas.openxmlformats.org/drawingml/2006/main">
             <a:pPr algn="r">
-              <a:defRPr sz="825" b="1">
+              <a:defRPr sz="1050" b="1">
                 <a:solidFill>
                   <a:srgbClr val="4DF0C0"/>
                 </a:solidFill>
@@ -2390,6 +2422,10 @@
             <a:prstDash val="solid"/>
           </a:ln>
         </p:spPr>
+        <p:txBody xmlns:a="http://schemas.openxmlformats.org/drawingml/2006/main">
+          <a:bodyPr/>
+          <a:p/>
+        </p:txBody>
       </p:sp>
       <p:sp>
         <p:nvSpPr>
@@ -2419,7 +2455,7 @@
           <a:lstStyle xmlns:a="http://schemas.openxmlformats.org/drawingml/2006/main"/>
           <a:p xmlns:a="http://schemas.openxmlformats.org/drawingml/2006/main">
             <a:pPr algn="l">
-              <a:defRPr sz="900" b="1">
+              <a:defRPr sz="1150" b="1">
                 <a:solidFill>
                   <a:srgbClr val="4DF0C0"/>
                 </a:solidFill>
@@ -2505,7 +2541,7 @@
           <a:lstStyle xmlns:a="http://schemas.openxmlformats.org/drawingml/2006/main"/>
           <a:p xmlns:a="http://schemas.openxmlformats.org/drawingml/2006/main">
             <a:pPr algn="l">
-              <a:defRPr sz="900" b="1">
+              <a:defRPr sz="1150" b="1">
                 <a:solidFill>
                   <a:srgbClr val="4DF0C0"/>
                 </a:solidFill>
@@ -2554,6 +2590,10 @@
             <a:prstDash val="solid"/>
           </a:ln>
         </p:spPr>
+        <p:txBody xmlns:a="http://schemas.openxmlformats.org/drawingml/2006/main">
+          <a:bodyPr/>
+          <a:p/>
+        </p:txBody>
       </p:sp>
       <p:sp>
         <p:nvSpPr>
@@ -2583,7 +2623,7 @@
           <a:lstStyle xmlns:a="http://schemas.openxmlformats.org/drawingml/2006/main"/>
           <a:p xmlns:a="http://schemas.openxmlformats.org/drawingml/2006/main">
             <a:pPr algn="l">
-              <a:defRPr sz="2025" b="1">
+              <a:defRPr sz="2125" b="1">
                 <a:solidFill>
                   <a:srgbClr val="4DF0C0"/>
                 </a:solidFill>
@@ -2673,6 +2713,10 @@
             <a:prstDash val="solid"/>
           </a:ln>
         </p:spPr>
+        <p:txBody xmlns:a="http://schemas.openxmlformats.org/drawingml/2006/main">
+          <a:bodyPr/>
+          <a:p/>
+        </p:txBody>
       </p:sp>
       <p:sp>
         <p:nvSpPr>
@@ -2702,7 +2746,7 @@
           <a:lstStyle xmlns:a="http://schemas.openxmlformats.org/drawingml/2006/main"/>
           <a:p xmlns:a="http://schemas.openxmlformats.org/drawingml/2006/main">
             <a:pPr algn="l">
-              <a:defRPr sz="900" b="1">
+              <a:defRPr sz="1150" b="1">
                 <a:solidFill>
                   <a:srgbClr val="4DF0C0"/>
                 </a:solidFill>
@@ -2792,6 +2836,10 @@
             <a:prstDash val="solid"/>
           </a:ln>
         </p:spPr>
+        <p:txBody xmlns:a="http://schemas.openxmlformats.org/drawingml/2006/main">
+          <a:bodyPr/>
+          <a:p/>
+        </p:txBody>
       </p:sp>
       <p:sp>
         <p:nvSpPr>
@@ -2821,7 +2869,7 @@
           <a:lstStyle xmlns:a="http://schemas.openxmlformats.org/drawingml/2006/main"/>
           <a:p xmlns:a="http://schemas.openxmlformats.org/drawingml/2006/main">
             <a:pPr algn="l">
-              <a:defRPr sz="900" b="1">
+              <a:defRPr sz="1150" b="1">
                 <a:solidFill>
                   <a:srgbClr val="4DF0C0"/>
                 </a:solidFill>
@@ -2911,6 +2959,10 @@
             <a:prstDash val="solid"/>
           </a:ln>
         </p:spPr>
+        <p:txBody xmlns:a="http://schemas.openxmlformats.org/drawingml/2006/main">
+          <a:bodyPr/>
+          <a:p/>
+        </p:txBody>
       </p:sp>
       <p:sp>
         <p:nvSpPr>
@@ -2940,7 +2992,7 @@
           <a:lstStyle xmlns:a="http://schemas.openxmlformats.org/drawingml/2006/main"/>
           <a:p xmlns:a="http://schemas.openxmlformats.org/drawingml/2006/main">
             <a:pPr algn="l">
-              <a:defRPr sz="900" b="1">
+              <a:defRPr sz="1150" b="1">
                 <a:solidFill>
                   <a:srgbClr val="4DF0C0"/>
                 </a:solidFill>
@@ -3026,7 +3078,7 @@
           <a:lstStyle xmlns:a="http://schemas.openxmlformats.org/drawingml/2006/main"/>
           <a:p xmlns:a="http://schemas.openxmlformats.org/drawingml/2006/main">
             <a:pPr algn="l">
-              <a:defRPr sz="900" b="1">
+              <a:defRPr sz="1150" b="1">
                 <a:solidFill>
                   <a:srgbClr val="5EA7FF"/>
                 </a:solidFill>
@@ -3075,6 +3127,10 @@
             <a:prstDash val="solid"/>
           </a:ln>
         </p:spPr>
+        <p:txBody xmlns:a="http://schemas.openxmlformats.org/drawingml/2006/main">
+          <a:bodyPr/>
+          <a:p/>
+        </p:txBody>
       </p:sp>
       <p:sp>
         <p:nvSpPr>
@@ -3104,7 +3160,7 @@
           <a:lstStyle xmlns:a="http://schemas.openxmlformats.org/drawingml/2006/main"/>
           <a:p xmlns:a="http://schemas.openxmlformats.org/drawingml/2006/main">
             <a:pPr algn="l">
-              <a:defRPr sz="1575" b="1">
+              <a:defRPr sz="1775" b="1">
                 <a:solidFill>
                   <a:srgbClr val="F4F8FF"/>
                 </a:solidFill>
@@ -3147,7 +3203,7 @@
           <a:lstStyle xmlns:a="http://schemas.openxmlformats.org/drawingml/2006/main"/>
           <a:p xmlns:a="http://schemas.openxmlformats.org/drawingml/2006/main">
             <a:pPr algn="l">
-              <a:defRPr sz="1125" b="0">
+              <a:defRPr sz="1400" b="0">
                 <a:solidFill>
                   <a:srgbClr val="5EA7FF"/>
                 </a:solidFill>
@@ -3190,7 +3246,7 @@
           <a:lstStyle xmlns:a="http://schemas.openxmlformats.org/drawingml/2006/main"/>
           <a:p xmlns:a="http://schemas.openxmlformats.org/drawingml/2006/main">
             <a:pPr algn="l">
-              <a:defRPr sz="1575" b="1">
+              <a:defRPr sz="1775" b="1">
                 <a:solidFill>
                   <a:srgbClr val="F4F8FF"/>
                 </a:solidFill>
@@ -3233,7 +3289,7 @@
           <a:lstStyle xmlns:a="http://schemas.openxmlformats.org/drawingml/2006/main"/>
           <a:p xmlns:a="http://schemas.openxmlformats.org/drawingml/2006/main">
             <a:pPr algn="l">
-              <a:defRPr sz="1125" b="0">
+              <a:defRPr sz="1400" b="0">
                 <a:solidFill>
                   <a:srgbClr val="5EA7FF"/>
                 </a:solidFill>
@@ -3276,7 +3332,7 @@
           <a:lstStyle xmlns:a="http://schemas.openxmlformats.org/drawingml/2006/main"/>
           <a:p xmlns:a="http://schemas.openxmlformats.org/drawingml/2006/main">
             <a:pPr algn="l">
-              <a:defRPr sz="1575" b="1">
+              <a:defRPr sz="1775" b="1">
                 <a:solidFill>
                   <a:srgbClr val="F4F8FF"/>
                 </a:solidFill>
@@ -3319,7 +3375,7 @@
           <a:lstStyle xmlns:a="http://schemas.openxmlformats.org/drawingml/2006/main"/>
           <a:p xmlns:a="http://schemas.openxmlformats.org/drawingml/2006/main">
             <a:pPr algn="l">
-              <a:defRPr sz="1125" b="0">
+              <a:defRPr sz="1400" b="0">
                 <a:solidFill>
                   <a:srgbClr val="5EA7FF"/>
                 </a:solidFill>
@@ -3362,7 +3418,7 @@
           <a:lstStyle xmlns:a="http://schemas.openxmlformats.org/drawingml/2006/main"/>
           <a:p xmlns:a="http://schemas.openxmlformats.org/drawingml/2006/main">
             <a:pPr algn="l">
-              <a:defRPr sz="1575" b="1">
+              <a:defRPr sz="1775" b="1">
                 <a:solidFill>
                   <a:srgbClr val="F4F8FF"/>
                 </a:solidFill>
@@ -3405,7 +3461,7 @@
           <a:lstStyle xmlns:a="http://schemas.openxmlformats.org/drawingml/2006/main"/>
           <a:p xmlns:a="http://schemas.openxmlformats.org/drawingml/2006/main">
             <a:pPr algn="l">
-              <a:defRPr sz="1125" b="0">
+              <a:defRPr sz="1400" b="0">
                 <a:solidFill>
                   <a:srgbClr val="5EA7FF"/>
                 </a:solidFill>
@@ -3452,6 +3508,10 @@
             <a:prstDash val="solid"/>
           </a:ln>
         </p:spPr>
+        <p:txBody xmlns:a="http://schemas.openxmlformats.org/drawingml/2006/main">
+          <a:bodyPr/>
+          <a:p/>
+        </p:txBody>
       </p:sp>
       <p:sp>
         <p:nvSpPr>
@@ -3481,7 +3541,7 @@
           <a:lstStyle xmlns:a="http://schemas.openxmlformats.org/drawingml/2006/main"/>
           <a:p xmlns:a="http://schemas.openxmlformats.org/drawingml/2006/main">
             <a:pPr algn="r">
-              <a:defRPr sz="900" b="1">
+              <a:defRPr sz="1150" b="1">
                 <a:solidFill>
                   <a:srgbClr val="FFB86B"/>
                 </a:solidFill>
@@ -3524,7 +3584,7 @@
           <a:lstStyle xmlns:a="http://schemas.openxmlformats.org/drawingml/2006/main"/>
           <a:p xmlns:a="http://schemas.openxmlformats.org/drawingml/2006/main">
             <a:pPr algn="l">
-              <a:defRPr sz="1800" b="1">
+              <a:defRPr sz="1925" b="1">
                 <a:solidFill>
                   <a:srgbClr val="F4F8FF"/>
                 </a:solidFill>
@@ -3567,7 +3627,7 @@
           <a:lstStyle xmlns:a="http://schemas.openxmlformats.org/drawingml/2006/main"/>
           <a:p xmlns:a="http://schemas.openxmlformats.org/drawingml/2006/main">
             <a:pPr algn="l">
-              <a:defRPr sz="750" b="0">
+              <a:defRPr sz="925" b="0">
                 <a:solidFill>
                   <a:srgbClr val="607792"/>
                 </a:solidFill>
@@ -3610,7 +3670,7 @@
           <a:lstStyle xmlns:a="http://schemas.openxmlformats.org/drawingml/2006/main"/>
           <a:p xmlns:a="http://schemas.openxmlformats.org/drawingml/2006/main">
             <a:pPr algn="r">
-              <a:defRPr sz="825" b="1">
+              <a:defRPr sz="1050" b="1">
                 <a:solidFill>
                   <a:srgbClr val="4DF0C0"/>
                 </a:solidFill>
@@ -3688,6 +3748,10 @@
             <a:prstDash val="solid"/>
           </a:ln>
         </p:spPr>
+        <p:txBody xmlns:a="http://schemas.openxmlformats.org/drawingml/2006/main">
+          <a:bodyPr/>
+          <a:p/>
+        </p:txBody>
       </p:sp>
       <p:sp>
         <p:nvSpPr>
@@ -3717,7 +3781,7 @@
           <a:lstStyle xmlns:a="http://schemas.openxmlformats.org/drawingml/2006/main"/>
           <a:p xmlns:a="http://schemas.openxmlformats.org/drawingml/2006/main">
             <a:pPr algn="l">
-              <a:defRPr sz="900" b="1">
+              <a:defRPr sz="1150" b="1">
                 <a:solidFill>
                   <a:srgbClr val="4DF0C0"/>
                 </a:solidFill>
@@ -3809,6 +3873,10 @@
             <a:prstDash val="solid"/>
           </a:ln>
         </p:spPr>
+        <p:txBody xmlns:a="http://schemas.openxmlformats.org/drawingml/2006/main">
+          <a:bodyPr/>
+          <a:p/>
+        </p:txBody>
       </p:sp>
       <p:sp>
         <p:nvSpPr>
@@ -3838,7 +3906,7 @@
           <a:lstStyle xmlns:a="http://schemas.openxmlformats.org/drawingml/2006/main"/>
           <a:p xmlns:a="http://schemas.openxmlformats.org/drawingml/2006/main">
             <a:pPr algn="l">
-              <a:defRPr sz="1200" b="1">
+              <a:defRPr sz="1300" b="1">
                 <a:solidFill>
                   <a:srgbClr val="F4F8FF"/>
                 </a:solidFill>
@@ -3930,6 +3998,10 @@
             <a:prstDash val="solid"/>
           </a:ln>
         </p:spPr>
+        <p:txBody xmlns:a="http://schemas.openxmlformats.org/drawingml/2006/main">
+          <a:bodyPr/>
+          <a:p/>
+        </p:txBody>
       </p:sp>
       <p:sp>
         <p:nvSpPr>
@@ -3959,7 +4031,7 @@
           <a:lstStyle xmlns:a="http://schemas.openxmlformats.org/drawingml/2006/main"/>
           <a:p xmlns:a="http://schemas.openxmlformats.org/drawingml/2006/main">
             <a:pPr algn="l">
-              <a:defRPr sz="1200" b="1">
+              <a:defRPr sz="1300" b="1">
                 <a:solidFill>
                   <a:srgbClr val="F4F8FF"/>
                 </a:solidFill>
@@ -4051,6 +4123,10 @@
             <a:prstDash val="solid"/>
           </a:ln>
         </p:spPr>
+        <p:txBody xmlns:a="http://schemas.openxmlformats.org/drawingml/2006/main">
+          <a:bodyPr/>
+          <a:p/>
+        </p:txBody>
       </p:sp>
       <p:sp>
         <p:nvSpPr>
@@ -4080,7 +4156,7 @@
           <a:lstStyle xmlns:a="http://schemas.openxmlformats.org/drawingml/2006/main"/>
           <a:p xmlns:a="http://schemas.openxmlformats.org/drawingml/2006/main">
             <a:pPr algn="l">
-              <a:defRPr sz="1200" b="1">
+              <a:defRPr sz="1300" b="1">
                 <a:solidFill>
                   <a:srgbClr val="F4F8FF"/>
                 </a:solidFill>
@@ -4172,6 +4248,10 @@
             <a:prstDash val="solid"/>
           </a:ln>
         </p:spPr>
+        <p:txBody xmlns:a="http://schemas.openxmlformats.org/drawingml/2006/main">
+          <a:bodyPr/>
+          <a:p/>
+        </p:txBody>
       </p:sp>
       <p:sp>
         <p:nvSpPr>
@@ -4201,7 +4281,7 @@
           <a:lstStyle xmlns:a="http://schemas.openxmlformats.org/drawingml/2006/main"/>
           <a:p xmlns:a="http://schemas.openxmlformats.org/drawingml/2006/main">
             <a:pPr algn="l">
-              <a:defRPr sz="1200" b="1">
+              <a:defRPr sz="1300" b="1">
                 <a:solidFill>
                   <a:srgbClr val="F4F8FF"/>
                 </a:solidFill>
@@ -4293,6 +4373,10 @@
             <a:prstDash val="solid"/>
           </a:ln>
         </p:spPr>
+        <p:txBody xmlns:a="http://schemas.openxmlformats.org/drawingml/2006/main">
+          <a:bodyPr/>
+          <a:p/>
+        </p:txBody>
       </p:sp>
       <p:sp>
         <p:nvSpPr>
@@ -4322,7 +4406,7 @@
           <a:lstStyle xmlns:a="http://schemas.openxmlformats.org/drawingml/2006/main"/>
           <a:p xmlns:a="http://schemas.openxmlformats.org/drawingml/2006/main">
             <a:pPr algn="l">
-              <a:defRPr sz="1200" b="1">
+              <a:defRPr sz="1300" b="1">
                 <a:solidFill>
                   <a:srgbClr val="F4F8FF"/>
                 </a:solidFill>
@@ -4414,6 +4498,10 @@
             <a:prstDash val="solid"/>
           </a:ln>
         </p:spPr>
+        <p:txBody xmlns:a="http://schemas.openxmlformats.org/drawingml/2006/main">
+          <a:bodyPr/>
+          <a:p/>
+        </p:txBody>
       </p:sp>
       <p:sp>
         <p:nvSpPr>
@@ -4443,7 +4531,7 @@
           <a:lstStyle xmlns:a="http://schemas.openxmlformats.org/drawingml/2006/main"/>
           <a:p xmlns:a="http://schemas.openxmlformats.org/drawingml/2006/main">
             <a:pPr algn="ctr">
-              <a:defRPr sz="1050" b="1">
+              <a:defRPr sz="1350" b="1">
                 <a:solidFill>
                   <a:srgbClr val="4DF0C0"/>
                 </a:solidFill>
@@ -4533,6 +4621,10 @@
             <a:prstDash val="solid"/>
           </a:ln>
         </p:spPr>
+        <p:txBody xmlns:a="http://schemas.openxmlformats.org/drawingml/2006/main">
+          <a:bodyPr/>
+          <a:p/>
+        </p:txBody>
       </p:sp>
       <p:sp>
         <p:nvSpPr>
@@ -4562,7 +4654,7 @@
           <a:lstStyle xmlns:a="http://schemas.openxmlformats.org/drawingml/2006/main"/>
           <a:p xmlns:a="http://schemas.openxmlformats.org/drawingml/2006/main">
             <a:pPr algn="ctr">
-              <a:defRPr sz="1650" b="0">
+              <a:defRPr sz="1775" b="0">
                 <a:solidFill>
                   <a:srgbClr val="90A2BA"/>
                 </a:solidFill>
@@ -4611,6 +4703,10 @@
             <a:prstDash val="solid"/>
           </a:ln>
         </p:spPr>
+        <p:txBody xmlns:a="http://schemas.openxmlformats.org/drawingml/2006/main">
+          <a:bodyPr/>
+          <a:p/>
+        </p:txBody>
       </p:sp>
       <p:sp>
         <p:nvSpPr>
@@ -4640,7 +4736,7 @@
           <a:lstStyle xmlns:a="http://schemas.openxmlformats.org/drawingml/2006/main"/>
           <a:p xmlns:a="http://schemas.openxmlformats.org/drawingml/2006/main">
             <a:pPr algn="ctr">
-              <a:defRPr sz="975" b="1">
+              <a:defRPr sz="1250" b="1">
                 <a:solidFill>
                   <a:srgbClr val="07111F"/>
                 </a:solidFill>
@@ -4726,7 +4822,7 @@
           <a:lstStyle xmlns:a="http://schemas.openxmlformats.org/drawingml/2006/main"/>
           <a:p xmlns:a="http://schemas.openxmlformats.org/drawingml/2006/main">
             <a:pPr algn="ctr">
-              <a:defRPr sz="975" b="1">
+              <a:defRPr sz="1175" b="1">
                 <a:solidFill>
                   <a:srgbClr val="07111F"/>
                 </a:solidFill>
@@ -4775,6 +4871,10 @@
             <a:prstDash val="solid"/>
           </a:ln>
         </p:spPr>
+        <p:txBody xmlns:a="http://schemas.openxmlformats.org/drawingml/2006/main">
+          <a:bodyPr/>
+          <a:p/>
+        </p:txBody>
       </p:sp>
       <p:sp>
         <p:nvSpPr>
@@ -4804,7 +4904,7 @@
           <a:lstStyle xmlns:a="http://schemas.openxmlformats.org/drawingml/2006/main"/>
           <a:p xmlns:a="http://schemas.openxmlformats.org/drawingml/2006/main">
             <a:pPr algn="l">
-              <a:defRPr sz="975" b="1">
+              <a:defRPr sz="1125" b="1">
                 <a:solidFill>
                   <a:srgbClr val="FFB86B"/>
                 </a:solidFill>
@@ -4847,7 +4947,7 @@
           <a:lstStyle xmlns:a="http://schemas.openxmlformats.org/drawingml/2006/main"/>
           <a:p xmlns:a="http://schemas.openxmlformats.org/drawingml/2006/main">
             <a:pPr algn="l">
-              <a:defRPr sz="750" b="1">
+              <a:defRPr sz="950" b="1">
                 <a:solidFill>
                   <a:srgbClr val="607792"/>
                 </a:solidFill>
@@ -4890,7 +4990,7 @@
           <a:lstStyle xmlns:a="http://schemas.openxmlformats.org/drawingml/2006/main"/>
           <a:p xmlns:a="http://schemas.openxmlformats.org/drawingml/2006/main">
             <a:pPr algn="l">
-              <a:defRPr sz="1275" b="0">
+              <a:defRPr sz="1325" b="0">
                 <a:solidFill>
                   <a:srgbClr val="F4F8FF"/>
                 </a:solidFill>
@@ -4933,7 +5033,7 @@
           <a:lstStyle xmlns:a="http://schemas.openxmlformats.org/drawingml/2006/main"/>
           <a:p xmlns:a="http://schemas.openxmlformats.org/drawingml/2006/main">
             <a:pPr algn="l">
-              <a:defRPr sz="750" b="1">
+              <a:defRPr sz="950" b="1">
                 <a:solidFill>
                   <a:srgbClr val="607792"/>
                 </a:solidFill>
@@ -4976,7 +5076,7 @@
           <a:lstStyle xmlns:a="http://schemas.openxmlformats.org/drawingml/2006/main"/>
           <a:p xmlns:a="http://schemas.openxmlformats.org/drawingml/2006/main">
             <a:pPr algn="l">
-              <a:defRPr sz="1275" b="0">
+              <a:defRPr sz="1325" b="0">
                 <a:solidFill>
                   <a:srgbClr val="F4F8FF"/>
                 </a:solidFill>
@@ -5019,7 +5119,7 @@
           <a:lstStyle xmlns:a="http://schemas.openxmlformats.org/drawingml/2006/main"/>
           <a:p xmlns:a="http://schemas.openxmlformats.org/drawingml/2006/main">
             <a:pPr algn="l">
-              <a:defRPr sz="750" b="1">
+              <a:defRPr sz="950" b="1">
                 <a:solidFill>
                   <a:srgbClr val="607792"/>
                 </a:solidFill>
@@ -5062,7 +5162,7 @@
           <a:lstStyle xmlns:a="http://schemas.openxmlformats.org/drawingml/2006/main"/>
           <a:p xmlns:a="http://schemas.openxmlformats.org/drawingml/2006/main">
             <a:pPr algn="l">
-              <a:defRPr sz="1275" b="0">
+              <a:defRPr sz="1325" b="0">
                 <a:solidFill>
                   <a:srgbClr val="F4F8FF"/>
                 </a:solidFill>
@@ -5105,7 +5205,7 @@
           <a:lstStyle xmlns:a="http://schemas.openxmlformats.org/drawingml/2006/main"/>
           <a:p xmlns:a="http://schemas.openxmlformats.org/drawingml/2006/main">
             <a:pPr algn="l">
-              <a:defRPr sz="750" b="1">
+              <a:defRPr sz="950" b="1">
                 <a:solidFill>
                   <a:srgbClr val="607792"/>
                 </a:solidFill>
@@ -5148,7 +5248,7 @@
           <a:lstStyle xmlns:a="http://schemas.openxmlformats.org/drawingml/2006/main"/>
           <a:p xmlns:a="http://schemas.openxmlformats.org/drawingml/2006/main">
             <a:pPr algn="l">
-              <a:defRPr sz="1275" b="0">
+              <a:defRPr sz="1325" b="0">
                 <a:solidFill>
                   <a:srgbClr val="F4F8FF"/>
                 </a:solidFill>
@@ -5373,7 +5473,7 @@
           <a:lstStyle xmlns:a="http://schemas.openxmlformats.org/drawingml/2006/main"/>
           <a:p xmlns:a="http://schemas.openxmlformats.org/drawingml/2006/main">
             <a:pPr algn="l">
-              <a:defRPr sz="1275" b="1">
+              <a:defRPr sz="1625" b="1">
                 <a:solidFill>
                   <a:srgbClr val="4DF0C0"/>
                 </a:solidFill>
@@ -5416,7 +5516,7 @@
           <a:lstStyle xmlns:a="http://schemas.openxmlformats.org/drawingml/2006/main"/>
           <a:p xmlns:a="http://schemas.openxmlformats.org/drawingml/2006/main">
             <a:pPr algn="l">
-              <a:defRPr sz="1275" b="1">
+              <a:defRPr sz="1450" b="1">
                 <a:solidFill>
                   <a:srgbClr val="FFB86B"/>
                 </a:solidFill>
@@ -5459,7 +5559,7 @@
           <a:lstStyle xmlns:a="http://schemas.openxmlformats.org/drawingml/2006/main"/>
           <a:p xmlns:a="http://schemas.openxmlformats.org/drawingml/2006/main">
             <a:pPr algn="l">
-              <a:defRPr sz="750" b="0">
+              <a:defRPr sz="925" b="0">
                 <a:solidFill>
                   <a:srgbClr val="607792"/>
                 </a:solidFill>
@@ -5502,7 +5602,7 @@
           <a:lstStyle xmlns:a="http://schemas.openxmlformats.org/drawingml/2006/main"/>
           <a:p xmlns:a="http://schemas.openxmlformats.org/drawingml/2006/main">
             <a:pPr algn="r">
-              <a:defRPr sz="825" b="1">
+              <a:defRPr sz="1050" b="1">
                 <a:solidFill>
                   <a:srgbClr val="4DF0C0"/>
                 </a:solidFill>
@@ -5580,6 +5680,10 @@
             <a:prstDash val="solid"/>
           </a:ln>
         </p:spPr>
+        <p:txBody xmlns:a="http://schemas.openxmlformats.org/drawingml/2006/main">
+          <a:bodyPr/>
+          <a:p/>
+        </p:txBody>
       </p:sp>
       <p:sp>
         <p:nvSpPr>
@@ -5609,7 +5713,7 @@
           <a:lstStyle xmlns:a="http://schemas.openxmlformats.org/drawingml/2006/main"/>
           <a:p xmlns:a="http://schemas.openxmlformats.org/drawingml/2006/main">
             <a:pPr algn="l">
-              <a:defRPr sz="900" b="1">
+              <a:defRPr sz="1150" b="1">
                 <a:solidFill>
                   <a:srgbClr val="4DF0C0"/>
                 </a:solidFill>
@@ -5652,7 +5756,7 @@
           <a:lstStyle xmlns:a="http://schemas.openxmlformats.org/drawingml/2006/main"/>
           <a:p xmlns:a="http://schemas.openxmlformats.org/drawingml/2006/main">
             <a:pPr algn="l">
-              <a:defRPr sz="2775" b="1">
+              <a:defRPr sz="2500" b="1">
                 <a:solidFill>
                   <a:srgbClr val="F4F8FF"/>
                 </a:solidFill>
@@ -5701,6 +5805,10 @@
             <a:prstDash val="solid"/>
           </a:ln>
         </p:spPr>
+        <p:txBody xmlns:a="http://schemas.openxmlformats.org/drawingml/2006/main">
+          <a:bodyPr/>
+          <a:p/>
+        </p:txBody>
       </p:sp>
       <p:pic>
         <p:nvPicPr>
@@ -5754,7 +5862,7 @@
           <a:lstStyle xmlns:a="http://schemas.openxmlformats.org/drawingml/2006/main"/>
           <a:p xmlns:a="http://schemas.openxmlformats.org/drawingml/2006/main">
             <a:pPr algn="l">
-              <a:defRPr sz="900" b="1">
+              <a:defRPr sz="1150" b="1">
                 <a:solidFill>
                   <a:srgbClr val="4DF0C0"/>
                 </a:solidFill>
@@ -5803,6 +5911,10 @@
             <a:prstDash val="solid"/>
           </a:ln>
         </p:spPr>
+        <p:txBody xmlns:a="http://schemas.openxmlformats.org/drawingml/2006/main">
+          <a:bodyPr/>
+          <a:p/>
+        </p:txBody>
       </p:sp>
       <p:sp>
         <p:nvSpPr>
@@ -5875,7 +5987,7 @@
           <a:lstStyle xmlns:a="http://schemas.openxmlformats.org/drawingml/2006/main"/>
           <a:p xmlns:a="http://schemas.openxmlformats.org/drawingml/2006/main">
             <a:pPr algn="l">
-              <a:defRPr sz="1050" b="0">
+              <a:defRPr sz="1300" b="0">
                 <a:solidFill>
                   <a:srgbClr val="90A2BA"/>
                 </a:solidFill>
@@ -5924,6 +6036,10 @@
             <a:prstDash val="solid"/>
           </a:ln>
         </p:spPr>
+        <p:txBody xmlns:a="http://schemas.openxmlformats.org/drawingml/2006/main">
+          <a:bodyPr/>
+          <a:p/>
+        </p:txBody>
       </p:sp>
       <p:sp>
         <p:nvSpPr>
@@ -5996,7 +6112,7 @@
           <a:lstStyle xmlns:a="http://schemas.openxmlformats.org/drawingml/2006/main"/>
           <a:p xmlns:a="http://schemas.openxmlformats.org/drawingml/2006/main">
             <a:pPr algn="l">
-              <a:defRPr sz="1050" b="0">
+              <a:defRPr sz="1300" b="0">
                 <a:solidFill>
                   <a:srgbClr val="90A2BA"/>
                 </a:solidFill>
@@ -6045,6 +6161,10 @@
             <a:prstDash val="solid"/>
           </a:ln>
         </p:spPr>
+        <p:txBody xmlns:a="http://schemas.openxmlformats.org/drawingml/2006/main">
+          <a:bodyPr/>
+          <a:p/>
+        </p:txBody>
       </p:sp>
       <p:sp>
         <p:nvSpPr>
@@ -6117,7 +6237,7 @@
           <a:lstStyle xmlns:a="http://schemas.openxmlformats.org/drawingml/2006/main"/>
           <a:p xmlns:a="http://schemas.openxmlformats.org/drawingml/2006/main">
             <a:pPr algn="l">
-              <a:defRPr sz="1050" b="0">
+              <a:defRPr sz="1300" b="0">
                 <a:solidFill>
                   <a:srgbClr val="90A2BA"/>
                 </a:solidFill>
@@ -6203,7 +6323,7 @@
           <a:lstStyle xmlns:a="http://schemas.openxmlformats.org/drawingml/2006/main"/>
           <a:p xmlns:a="http://schemas.openxmlformats.org/drawingml/2006/main">
             <a:pPr algn="l">
-              <a:defRPr sz="750" b="0">
+              <a:defRPr sz="925" b="0">
                 <a:solidFill>
                   <a:srgbClr val="607792"/>
                 </a:solidFill>
@@ -6246,7 +6366,7 @@
           <a:lstStyle xmlns:a="http://schemas.openxmlformats.org/drawingml/2006/main"/>
           <a:p xmlns:a="http://schemas.openxmlformats.org/drawingml/2006/main">
             <a:pPr algn="r">
-              <a:defRPr sz="825" b="1">
+              <a:defRPr sz="1050" b="1">
                 <a:solidFill>
                   <a:srgbClr val="4DF0C0"/>
                 </a:solidFill>
@@ -6324,6 +6444,10 @@
             <a:prstDash val="solid"/>
           </a:ln>
         </p:spPr>
+        <p:txBody xmlns:a="http://schemas.openxmlformats.org/drawingml/2006/main">
+          <a:bodyPr/>
+          <a:p/>
+        </p:txBody>
       </p:sp>
       <p:sp>
         <p:nvSpPr>
@@ -6353,7 +6477,7 @@
           <a:lstStyle xmlns:a="http://schemas.openxmlformats.org/drawingml/2006/main"/>
           <a:p xmlns:a="http://schemas.openxmlformats.org/drawingml/2006/main">
             <a:pPr algn="l">
-              <a:defRPr sz="900" b="1">
+              <a:defRPr sz="1150" b="1">
                 <a:solidFill>
                   <a:srgbClr val="4DF0C0"/>
                 </a:solidFill>
@@ -6445,6 +6569,10 @@
             <a:prstDash val="solid"/>
           </a:ln>
         </p:spPr>
+        <p:txBody xmlns:a="http://schemas.openxmlformats.org/drawingml/2006/main">
+          <a:bodyPr/>
+          <a:p/>
+        </p:txBody>
       </p:sp>
       <p:sp>
         <p:nvSpPr>
@@ -6474,7 +6602,7 @@
           <a:lstStyle xmlns:a="http://schemas.openxmlformats.org/drawingml/2006/main"/>
           <a:p xmlns:a="http://schemas.openxmlformats.org/drawingml/2006/main">
             <a:pPr algn="l">
-              <a:defRPr sz="1350" b="1">
+              <a:defRPr sz="1625" b="1">
                 <a:solidFill>
                   <a:srgbClr val="5EA7FF"/>
                 </a:solidFill>
@@ -6517,7 +6645,7 @@
           <a:lstStyle xmlns:a="http://schemas.openxmlformats.org/drawingml/2006/main"/>
           <a:p xmlns:a="http://schemas.openxmlformats.org/drawingml/2006/main">
             <a:pPr algn="l">
-              <a:defRPr sz="1050" b="1">
+              <a:defRPr sz="1350" b="1">
                 <a:solidFill>
                   <a:srgbClr val="5EA7FF"/>
                 </a:solidFill>
@@ -6560,7 +6688,7 @@
           <a:lstStyle xmlns:a="http://schemas.openxmlformats.org/drawingml/2006/main"/>
           <a:p xmlns:a="http://schemas.openxmlformats.org/drawingml/2006/main">
             <a:pPr algn="l">
-              <a:defRPr sz="1425" b="0">
+              <a:defRPr sz="1525" b="0">
                 <a:solidFill>
                   <a:srgbClr val="F4F8FF"/>
                 </a:solidFill>
@@ -6609,6 +6737,10 @@
             <a:prstDash val="solid"/>
           </a:ln>
         </p:spPr>
+        <p:txBody xmlns:a="http://schemas.openxmlformats.org/drawingml/2006/main">
+          <a:bodyPr/>
+          <a:p/>
+        </p:txBody>
       </p:sp>
       <p:sp>
         <p:nvSpPr>
@@ -6638,7 +6770,7 @@
           <a:lstStyle xmlns:a="http://schemas.openxmlformats.org/drawingml/2006/main"/>
           <a:p xmlns:a="http://schemas.openxmlformats.org/drawingml/2006/main">
             <a:pPr algn="l">
-              <a:defRPr sz="1350" b="1">
+              <a:defRPr sz="1625" b="1">
                 <a:solidFill>
                   <a:srgbClr val="5EA7FF"/>
                 </a:solidFill>
@@ -6681,7 +6813,7 @@
           <a:lstStyle xmlns:a="http://schemas.openxmlformats.org/drawingml/2006/main"/>
           <a:p xmlns:a="http://schemas.openxmlformats.org/drawingml/2006/main">
             <a:pPr algn="l">
-              <a:defRPr sz="1050" b="1">
+              <a:defRPr sz="1350" b="1">
                 <a:solidFill>
                   <a:srgbClr val="5EA7FF"/>
                 </a:solidFill>
@@ -6724,7 +6856,7 @@
           <a:lstStyle xmlns:a="http://schemas.openxmlformats.org/drawingml/2006/main"/>
           <a:p xmlns:a="http://schemas.openxmlformats.org/drawingml/2006/main">
             <a:pPr algn="l">
-              <a:defRPr sz="1425" b="0">
+              <a:defRPr sz="1525" b="0">
                 <a:solidFill>
                   <a:srgbClr val="F4F8FF"/>
                 </a:solidFill>
@@ -6773,6 +6905,10 @@
             <a:prstDash val="solid"/>
           </a:ln>
         </p:spPr>
+        <p:txBody xmlns:a="http://schemas.openxmlformats.org/drawingml/2006/main">
+          <a:bodyPr/>
+          <a:p/>
+        </p:txBody>
       </p:sp>
       <p:sp>
         <p:nvSpPr>
@@ -6802,7 +6938,7 @@
           <a:lstStyle xmlns:a="http://schemas.openxmlformats.org/drawingml/2006/main"/>
           <a:p xmlns:a="http://schemas.openxmlformats.org/drawingml/2006/main">
             <a:pPr algn="l">
-              <a:defRPr sz="1350" b="1">
+              <a:defRPr sz="1625" b="1">
                 <a:solidFill>
                   <a:srgbClr val="5EA7FF"/>
                 </a:solidFill>
@@ -6845,7 +6981,7 @@
           <a:lstStyle xmlns:a="http://schemas.openxmlformats.org/drawingml/2006/main"/>
           <a:p xmlns:a="http://schemas.openxmlformats.org/drawingml/2006/main">
             <a:pPr algn="l">
-              <a:defRPr sz="1050" b="1">
+              <a:defRPr sz="1350" b="1">
                 <a:solidFill>
                   <a:srgbClr val="5EA7FF"/>
                 </a:solidFill>
@@ -6888,7 +7024,7 @@
           <a:lstStyle xmlns:a="http://schemas.openxmlformats.org/drawingml/2006/main"/>
           <a:p xmlns:a="http://schemas.openxmlformats.org/drawingml/2006/main">
             <a:pPr algn="l">
-              <a:defRPr sz="1425" b="0">
+              <a:defRPr sz="1525" b="0">
                 <a:solidFill>
                   <a:srgbClr val="F4F8FF"/>
                 </a:solidFill>
@@ -6937,6 +7073,10 @@
             <a:prstDash val="solid"/>
           </a:ln>
         </p:spPr>
+        <p:txBody xmlns:a="http://schemas.openxmlformats.org/drawingml/2006/main">
+          <a:bodyPr/>
+          <a:p/>
+        </p:txBody>
       </p:sp>
       <p:sp>
         <p:nvSpPr>
@@ -6966,7 +7106,7 @@
           <a:lstStyle xmlns:a="http://schemas.openxmlformats.org/drawingml/2006/main"/>
           <a:p xmlns:a="http://schemas.openxmlformats.org/drawingml/2006/main">
             <a:pPr algn="l">
-              <a:defRPr sz="1350" b="1">
+              <a:defRPr sz="1625" b="1">
                 <a:solidFill>
                   <a:srgbClr val="FFB86B"/>
                 </a:solidFill>
@@ -7009,7 +7149,7 @@
           <a:lstStyle xmlns:a="http://schemas.openxmlformats.org/drawingml/2006/main"/>
           <a:p xmlns:a="http://schemas.openxmlformats.org/drawingml/2006/main">
             <a:pPr algn="l">
-              <a:defRPr sz="1050" b="1">
+              <a:defRPr sz="1350" b="1">
                 <a:solidFill>
                   <a:srgbClr val="FFB86B"/>
                 </a:solidFill>
@@ -7052,7 +7192,7 @@
           <a:lstStyle xmlns:a="http://schemas.openxmlformats.org/drawingml/2006/main"/>
           <a:p xmlns:a="http://schemas.openxmlformats.org/drawingml/2006/main">
             <a:pPr algn="l">
-              <a:defRPr sz="1425" b="0">
+              <a:defRPr sz="1525" b="0">
                 <a:solidFill>
                   <a:srgbClr val="F4F8FF"/>
                 </a:solidFill>
@@ -7101,6 +7241,10 @@
             <a:prstDash val="solid"/>
           </a:ln>
         </p:spPr>
+        <p:txBody xmlns:a="http://schemas.openxmlformats.org/drawingml/2006/main">
+          <a:bodyPr/>
+          <a:p/>
+        </p:txBody>
       </p:sp>
       <p:sp>
         <p:nvSpPr>
@@ -7130,7 +7274,7 @@
           <a:lstStyle xmlns:a="http://schemas.openxmlformats.org/drawingml/2006/main"/>
           <a:p xmlns:a="http://schemas.openxmlformats.org/drawingml/2006/main">
             <a:pPr algn="l">
-              <a:defRPr sz="1350" b="1">
+              <a:defRPr sz="1625" b="1">
                 <a:solidFill>
                   <a:srgbClr val="5EA7FF"/>
                 </a:solidFill>
@@ -7173,7 +7317,7 @@
           <a:lstStyle xmlns:a="http://schemas.openxmlformats.org/drawingml/2006/main"/>
           <a:p xmlns:a="http://schemas.openxmlformats.org/drawingml/2006/main">
             <a:pPr algn="l">
-              <a:defRPr sz="1050" b="1">
+              <a:defRPr sz="1350" b="1">
                 <a:solidFill>
                   <a:srgbClr val="5EA7FF"/>
                 </a:solidFill>
@@ -7216,7 +7360,7 @@
           <a:lstStyle xmlns:a="http://schemas.openxmlformats.org/drawingml/2006/main"/>
           <a:p xmlns:a="http://schemas.openxmlformats.org/drawingml/2006/main">
             <a:pPr algn="l">
-              <a:defRPr sz="1425" b="0">
+              <a:defRPr sz="1525" b="0">
                 <a:solidFill>
                   <a:srgbClr val="F4F8FF"/>
                 </a:solidFill>
@@ -7265,6 +7409,10 @@
             <a:prstDash val="solid"/>
           </a:ln>
         </p:spPr>
+        <p:txBody xmlns:a="http://schemas.openxmlformats.org/drawingml/2006/main">
+          <a:bodyPr/>
+          <a:p/>
+        </p:txBody>
       </p:sp>
       <p:sp>
         <p:nvSpPr>
@@ -7294,7 +7442,7 @@
           <a:lstStyle xmlns:a="http://schemas.openxmlformats.org/drawingml/2006/main"/>
           <a:p xmlns:a="http://schemas.openxmlformats.org/drawingml/2006/main">
             <a:pPr algn="l">
-              <a:defRPr sz="1350" b="1">
+              <a:defRPr sz="1625" b="1">
                 <a:solidFill>
                   <a:srgbClr val="4DF0C0"/>
                 </a:solidFill>
@@ -7337,7 +7485,7 @@
           <a:lstStyle xmlns:a="http://schemas.openxmlformats.org/drawingml/2006/main"/>
           <a:p xmlns:a="http://schemas.openxmlformats.org/drawingml/2006/main">
             <a:pPr algn="l">
-              <a:defRPr sz="1050" b="1">
+              <a:defRPr sz="1350" b="1">
                 <a:solidFill>
                   <a:srgbClr val="4DF0C0"/>
                 </a:solidFill>
@@ -7380,7 +7528,7 @@
           <a:lstStyle xmlns:a="http://schemas.openxmlformats.org/drawingml/2006/main"/>
           <a:p xmlns:a="http://schemas.openxmlformats.org/drawingml/2006/main">
             <a:pPr algn="l">
-              <a:defRPr sz="1425" b="0">
+              <a:defRPr sz="1525" b="0">
                 <a:solidFill>
                   <a:srgbClr val="F4F8FF"/>
                 </a:solidFill>
@@ -7429,6 +7577,10 @@
             <a:prstDash val="solid"/>
           </a:ln>
         </p:spPr>
+        <p:txBody xmlns:a="http://schemas.openxmlformats.org/drawingml/2006/main">
+          <a:bodyPr/>
+          <a:p/>
+        </p:txBody>
       </p:sp>
       <p:sp>
         <p:nvSpPr>
@@ -7458,7 +7610,7 @@
           <a:lstStyle xmlns:a="http://schemas.openxmlformats.org/drawingml/2006/main"/>
           <a:p xmlns:a="http://schemas.openxmlformats.org/drawingml/2006/main">
             <a:pPr algn="l">
-              <a:defRPr sz="1350" b="1">
+              <a:defRPr sz="1625" b="1">
                 <a:solidFill>
                   <a:srgbClr val="4DF0C0"/>
                 </a:solidFill>
@@ -7501,7 +7653,7 @@
           <a:lstStyle xmlns:a="http://schemas.openxmlformats.org/drawingml/2006/main"/>
           <a:p xmlns:a="http://schemas.openxmlformats.org/drawingml/2006/main">
             <a:pPr algn="l">
-              <a:defRPr sz="1050" b="1">
+              <a:defRPr sz="1350" b="1">
                 <a:solidFill>
                   <a:srgbClr val="4DF0C0"/>
                 </a:solidFill>
@@ -7544,7 +7696,7 @@
           <a:lstStyle xmlns:a="http://schemas.openxmlformats.org/drawingml/2006/main"/>
           <a:p xmlns:a="http://schemas.openxmlformats.org/drawingml/2006/main">
             <a:pPr algn="l">
-              <a:defRPr sz="1425" b="0">
+              <a:defRPr sz="1525" b="0">
                 <a:solidFill>
                   <a:srgbClr val="F4F8FF"/>
                 </a:solidFill>
@@ -7593,6 +7745,10 @@
             <a:prstDash val="solid"/>
           </a:ln>
         </p:spPr>
+        <p:txBody xmlns:a="http://schemas.openxmlformats.org/drawingml/2006/main">
+          <a:bodyPr/>
+          <a:p/>
+        </p:txBody>
       </p:sp>
       <p:sp>
         <p:nvSpPr>
@@ -7622,7 +7778,7 @@
           <a:lstStyle xmlns:a="http://schemas.openxmlformats.org/drawingml/2006/main"/>
           <a:p xmlns:a="http://schemas.openxmlformats.org/drawingml/2006/main">
             <a:pPr algn="l">
-              <a:defRPr sz="1350" b="1">
+              <a:defRPr sz="1625" b="1">
                 <a:solidFill>
                   <a:srgbClr val="4DF0C0"/>
                 </a:solidFill>
@@ -7665,7 +7821,7 @@
           <a:lstStyle xmlns:a="http://schemas.openxmlformats.org/drawingml/2006/main"/>
           <a:p xmlns:a="http://schemas.openxmlformats.org/drawingml/2006/main">
             <a:pPr algn="l">
-              <a:defRPr sz="1050" b="1">
+              <a:defRPr sz="1350" b="1">
                 <a:solidFill>
                   <a:srgbClr val="4DF0C0"/>
                 </a:solidFill>
@@ -7708,7 +7864,7 @@
           <a:lstStyle xmlns:a="http://schemas.openxmlformats.org/drawingml/2006/main"/>
           <a:p xmlns:a="http://schemas.openxmlformats.org/drawingml/2006/main">
             <a:pPr algn="l">
-              <a:defRPr sz="1425" b="0">
+              <a:defRPr sz="1525" b="0">
                 <a:solidFill>
                   <a:srgbClr val="F4F8FF"/>
                 </a:solidFill>
@@ -8058,6 +8214,10 @@
             <a:prstDash val="solid"/>
           </a:ln>
         </p:spPr>
+        <p:txBody xmlns:a="http://schemas.openxmlformats.org/drawingml/2006/main">
+          <a:bodyPr/>
+          <a:p/>
+        </p:txBody>
       </p:sp>
       <p:sp>
         <p:nvSpPr>
@@ -8087,7 +8247,7 @@
           <a:lstStyle xmlns:a="http://schemas.openxmlformats.org/drawingml/2006/main"/>
           <a:p xmlns:a="http://schemas.openxmlformats.org/drawingml/2006/main">
             <a:pPr algn="ctr">
-              <a:defRPr sz="900" b="1">
+              <a:defRPr sz="1050" b="1">
                 <a:solidFill>
                   <a:srgbClr val="07111F"/>
                 </a:solidFill>
@@ -8130,7 +8290,7 @@
           <a:lstStyle xmlns:a="http://schemas.openxmlformats.org/drawingml/2006/main"/>
           <a:p xmlns:a="http://schemas.openxmlformats.org/drawingml/2006/main">
             <a:pPr algn="l">
-              <a:defRPr sz="750" b="0">
+              <a:defRPr sz="925" b="0">
                 <a:solidFill>
                   <a:srgbClr val="607792"/>
                 </a:solidFill>
@@ -8173,7 +8333,7 @@
           <a:lstStyle xmlns:a="http://schemas.openxmlformats.org/drawingml/2006/main"/>
           <a:p xmlns:a="http://schemas.openxmlformats.org/drawingml/2006/main">
             <a:pPr algn="r">
-              <a:defRPr sz="825" b="1">
+              <a:defRPr sz="1050" b="1">
                 <a:solidFill>
                   <a:srgbClr val="4DF0C0"/>
                 </a:solidFill>
@@ -8251,6 +8411,10 @@
             <a:prstDash val="solid"/>
           </a:ln>
         </p:spPr>
+        <p:txBody xmlns:a="http://schemas.openxmlformats.org/drawingml/2006/main">
+          <a:bodyPr/>
+          <a:p/>
+        </p:txBody>
       </p:sp>
       <p:sp>
         <p:nvSpPr>
@@ -8280,7 +8444,7 @@
           <a:lstStyle xmlns:a="http://schemas.openxmlformats.org/drawingml/2006/main"/>
           <a:p xmlns:a="http://schemas.openxmlformats.org/drawingml/2006/main">
             <a:pPr algn="l">
-              <a:defRPr sz="900" b="1">
+              <a:defRPr sz="1150" b="1">
                 <a:solidFill>
                   <a:srgbClr val="4DF0C0"/>
                 </a:solidFill>
@@ -8372,6 +8536,10 @@
             <a:prstDash val="solid"/>
           </a:ln>
         </p:spPr>
+        <p:txBody xmlns:a="http://schemas.openxmlformats.org/drawingml/2006/main">
+          <a:bodyPr/>
+          <a:p/>
+        </p:txBody>
       </p:sp>
       <p:sp>
         <p:nvSpPr>
@@ -8401,7 +8569,7 @@
           <a:lstStyle xmlns:a="http://schemas.openxmlformats.org/drawingml/2006/main"/>
           <a:p xmlns:a="http://schemas.openxmlformats.org/drawingml/2006/main">
             <a:pPr algn="l">
-              <a:defRPr sz="900" b="1">
+              <a:defRPr sz="1150" b="1">
                 <a:solidFill>
                   <a:srgbClr val="4DF0C0"/>
                 </a:solidFill>
@@ -8487,7 +8655,7 @@
           <a:lstStyle xmlns:a="http://schemas.openxmlformats.org/drawingml/2006/main"/>
           <a:p xmlns:a="http://schemas.openxmlformats.org/drawingml/2006/main">
             <a:pPr algn="l">
-              <a:defRPr sz="1575" b="0">
+              <a:defRPr sz="1650" b="0">
                 <a:solidFill>
                   <a:srgbClr val="90A2BA"/>
                 </a:solidFill>
@@ -8530,7 +8698,7 @@
           <a:lstStyle xmlns:a="http://schemas.openxmlformats.org/drawingml/2006/main"/>
           <a:p xmlns:a="http://schemas.openxmlformats.org/drawingml/2006/main">
             <a:pPr algn="l">
-              <a:defRPr sz="1200" b="0">
+              <a:defRPr sz="1450" b="0">
                 <a:solidFill>
                   <a:srgbClr val="F4F8FF"/>
                 </a:solidFill>
@@ -8579,6 +8747,10 @@
             <a:prstDash val="solid"/>
           </a:ln>
         </p:spPr>
+        <p:txBody xmlns:a="http://schemas.openxmlformats.org/drawingml/2006/main">
+          <a:bodyPr/>
+          <a:p/>
+        </p:txBody>
       </p:sp>
       <p:sp>
         <p:nvSpPr>
@@ -8608,7 +8780,7 @@
           <a:lstStyle xmlns:a="http://schemas.openxmlformats.org/drawingml/2006/main"/>
           <a:p xmlns:a="http://schemas.openxmlformats.org/drawingml/2006/main">
             <a:pPr algn="ctr">
-              <a:defRPr sz="1125" b="1">
+              <a:defRPr sz="1400" b="1">
                 <a:solidFill>
                   <a:srgbClr val="5EA7FF"/>
                 </a:solidFill>
@@ -8700,6 +8872,10 @@
             <a:prstDash val="solid"/>
           </a:ln>
         </p:spPr>
+        <p:txBody xmlns:a="http://schemas.openxmlformats.org/drawingml/2006/main">
+          <a:bodyPr/>
+          <a:p/>
+        </p:txBody>
       </p:sp>
       <p:sp>
         <p:nvSpPr>
@@ -8729,7 +8905,7 @@
           <a:lstStyle xmlns:a="http://schemas.openxmlformats.org/drawingml/2006/main"/>
           <a:p xmlns:a="http://schemas.openxmlformats.org/drawingml/2006/main">
             <a:pPr algn="ctr">
-              <a:defRPr sz="1125" b="1">
+              <a:defRPr sz="1400" b="1">
                 <a:solidFill>
                   <a:srgbClr val="FFB86B"/>
                 </a:solidFill>
@@ -8821,6 +8997,10 @@
             <a:prstDash val="solid"/>
           </a:ln>
         </p:spPr>
+        <p:txBody xmlns:a="http://schemas.openxmlformats.org/drawingml/2006/main">
+          <a:bodyPr/>
+          <a:p/>
+        </p:txBody>
       </p:sp>
       <p:sp>
         <p:nvSpPr>
@@ -8850,7 +9030,7 @@
           <a:lstStyle xmlns:a="http://schemas.openxmlformats.org/drawingml/2006/main"/>
           <a:p xmlns:a="http://schemas.openxmlformats.org/drawingml/2006/main">
             <a:pPr algn="ctr">
-              <a:defRPr sz="1125" b="1">
+              <a:defRPr sz="1400" b="1">
                 <a:solidFill>
                   <a:srgbClr val="4DF0C0"/>
                 </a:solidFill>
@@ -8942,6 +9122,10 @@
             <a:prstDash val="solid"/>
           </a:ln>
         </p:spPr>
+        <p:txBody xmlns:a="http://schemas.openxmlformats.org/drawingml/2006/main">
+          <a:bodyPr/>
+          <a:p/>
+        </p:txBody>
       </p:sp>
       <p:sp>
         <p:nvSpPr>
@@ -8971,7 +9155,7 @@
           <a:lstStyle xmlns:a="http://schemas.openxmlformats.org/drawingml/2006/main"/>
           <a:p xmlns:a="http://schemas.openxmlformats.org/drawingml/2006/main">
             <a:pPr algn="ctr">
-              <a:defRPr sz="1125" b="1">
+              <a:defRPr sz="1400" b="1">
                 <a:solidFill>
                   <a:srgbClr val="C989FF"/>
                 </a:solidFill>
@@ -9100,7 +9284,7 @@
           <a:lstStyle xmlns:a="http://schemas.openxmlformats.org/drawingml/2006/main"/>
           <a:p xmlns:a="http://schemas.openxmlformats.org/drawingml/2006/main">
             <a:pPr algn="ctr">
-              <a:defRPr sz="1500" b="1">
+              <a:defRPr sz="1775" b="1">
                 <a:solidFill>
                   <a:srgbClr val="F4F8FF"/>
                 </a:solidFill>
@@ -9186,7 +9370,7 @@
           <a:lstStyle xmlns:a="http://schemas.openxmlformats.org/drawingml/2006/main"/>
           <a:p xmlns:a="http://schemas.openxmlformats.org/drawingml/2006/main">
             <a:pPr algn="l">
-              <a:defRPr sz="900" b="1">
+              <a:defRPr sz="1150" b="1">
                 <a:solidFill>
                   <a:srgbClr val="5EA7FF"/>
                 </a:solidFill>
@@ -9229,7 +9413,7 @@
           <a:lstStyle xmlns:a="http://schemas.openxmlformats.org/drawingml/2006/main"/>
           <a:p xmlns:a="http://schemas.openxmlformats.org/drawingml/2006/main">
             <a:pPr algn="l">
-              <a:defRPr sz="975" b="1">
+              <a:defRPr sz="1250" b="1">
                 <a:solidFill>
                   <a:srgbClr val="4DF0C0"/>
                 </a:solidFill>
@@ -9315,7 +9499,7 @@
           <a:lstStyle xmlns:a="http://schemas.openxmlformats.org/drawingml/2006/main"/>
           <a:p xmlns:a="http://schemas.openxmlformats.org/drawingml/2006/main">
             <a:pPr algn="l">
-              <a:defRPr sz="975" b="1">
+              <a:defRPr sz="1250" b="1">
                 <a:solidFill>
                   <a:srgbClr val="4DF0C0"/>
                 </a:solidFill>
@@ -9401,7 +9585,7 @@
           <a:lstStyle xmlns:a="http://schemas.openxmlformats.org/drawingml/2006/main"/>
           <a:p xmlns:a="http://schemas.openxmlformats.org/drawingml/2006/main">
             <a:pPr algn="l">
-              <a:defRPr sz="975" b="1">
+              <a:defRPr sz="1250" b="1">
                 <a:solidFill>
                   <a:srgbClr val="4DF0C0"/>
                 </a:solidFill>
@@ -9487,7 +9671,7 @@
           <a:lstStyle xmlns:a="http://schemas.openxmlformats.org/drawingml/2006/main"/>
           <a:p xmlns:a="http://schemas.openxmlformats.org/drawingml/2006/main">
             <a:pPr algn="l">
-              <a:defRPr sz="975" b="1">
+              <a:defRPr sz="1250" b="1">
                 <a:solidFill>
                   <a:srgbClr val="4DF0C0"/>
                 </a:solidFill>
@@ -9579,6 +9763,10 @@
             <a:prstDash val="solid"/>
           </a:ln>
         </p:spPr>
+        <p:txBody xmlns:a="http://schemas.openxmlformats.org/drawingml/2006/main">
+          <a:bodyPr/>
+          <a:p/>
+        </p:txBody>
       </p:sp>
       <p:sp>
         <p:nvSpPr>
@@ -9608,7 +9796,7 @@
           <a:lstStyle xmlns:a="http://schemas.openxmlformats.org/drawingml/2006/main"/>
           <a:p xmlns:a="http://schemas.openxmlformats.org/drawingml/2006/main">
             <a:pPr algn="ctr">
-              <a:defRPr sz="1125" b="1">
+              <a:defRPr sz="1175" b="1">
                 <a:solidFill>
                   <a:srgbClr val="F4F8FF"/>
                 </a:solidFill>
@@ -9651,7 +9839,7 @@
           <a:lstStyle xmlns:a="http://schemas.openxmlformats.org/drawingml/2006/main"/>
           <a:p xmlns:a="http://schemas.openxmlformats.org/drawingml/2006/main">
             <a:pPr algn="l">
-              <a:defRPr sz="750" b="0">
+              <a:defRPr sz="925" b="0">
                 <a:solidFill>
                   <a:srgbClr val="607792"/>
                 </a:solidFill>
@@ -9694,7 +9882,7 @@
           <a:lstStyle xmlns:a="http://schemas.openxmlformats.org/drawingml/2006/main"/>
           <a:p xmlns:a="http://schemas.openxmlformats.org/drawingml/2006/main">
             <a:pPr algn="r">
-              <a:defRPr sz="825" b="1">
+              <a:defRPr sz="1050" b="1">
                 <a:solidFill>
                   <a:srgbClr val="4DF0C0"/>
                 </a:solidFill>
@@ -9772,6 +9960,10 @@
             <a:prstDash val="solid"/>
           </a:ln>
         </p:spPr>
+        <p:txBody xmlns:a="http://schemas.openxmlformats.org/drawingml/2006/main">
+          <a:bodyPr/>
+          <a:p/>
+        </p:txBody>
       </p:sp>
       <p:sp>
         <p:nvSpPr>
@@ -9801,7 +9993,7 @@
           <a:lstStyle xmlns:a="http://schemas.openxmlformats.org/drawingml/2006/main"/>
           <a:p xmlns:a="http://schemas.openxmlformats.org/drawingml/2006/main">
             <a:pPr algn="l">
-              <a:defRPr sz="900" b="1">
+              <a:defRPr sz="1150" b="1">
                 <a:solidFill>
                   <a:srgbClr val="4DF0C0"/>
                 </a:solidFill>
@@ -9887,7 +10079,7 @@
           <a:lstStyle xmlns:a="http://schemas.openxmlformats.org/drawingml/2006/main"/>
           <a:p xmlns:a="http://schemas.openxmlformats.org/drawingml/2006/main">
             <a:pPr algn="l">
-              <a:defRPr sz="900" b="1">
+              <a:defRPr sz="1150" b="1">
                 <a:solidFill>
                   <a:srgbClr val="FFB86B"/>
                 </a:solidFill>
@@ -9930,7 +10122,7 @@
           <a:lstStyle xmlns:a="http://schemas.openxmlformats.org/drawingml/2006/main"/>
           <a:p xmlns:a="http://schemas.openxmlformats.org/drawingml/2006/main">
             <a:pPr algn="l">
-              <a:defRPr sz="975" b="1">
+              <a:defRPr sz="1250" b="1">
                 <a:solidFill>
                   <a:srgbClr val="FFB86B"/>
                 </a:solidFill>
@@ -10016,7 +10208,7 @@
           <a:lstStyle xmlns:a="http://schemas.openxmlformats.org/drawingml/2006/main"/>
           <a:p xmlns:a="http://schemas.openxmlformats.org/drawingml/2006/main">
             <a:pPr algn="l">
-              <a:defRPr sz="1200" b="0">
+              <a:defRPr sz="1400" b="0">
                 <a:solidFill>
                   <a:srgbClr val="90A2BA"/>
                 </a:solidFill>
@@ -10063,6 +10255,10 @@
             <a:prstDash val="solid"/>
           </a:ln>
         </p:spPr>
+        <p:txBody xmlns:a="http://schemas.openxmlformats.org/drawingml/2006/main">
+          <a:bodyPr/>
+          <a:p/>
+        </p:txBody>
       </p:sp>
       <p:sp>
         <p:nvSpPr>
@@ -10092,7 +10288,7 @@
           <a:lstStyle xmlns:a="http://schemas.openxmlformats.org/drawingml/2006/main"/>
           <a:p xmlns:a="http://schemas.openxmlformats.org/drawingml/2006/main">
             <a:pPr algn="l">
-              <a:defRPr sz="975" b="1">
+              <a:defRPr sz="1250" b="1">
                 <a:solidFill>
                   <a:srgbClr val="FFB86B"/>
                 </a:solidFill>
@@ -10178,7 +10374,7 @@
           <a:lstStyle xmlns:a="http://schemas.openxmlformats.org/drawingml/2006/main"/>
           <a:p xmlns:a="http://schemas.openxmlformats.org/drawingml/2006/main">
             <a:pPr algn="l">
-              <a:defRPr sz="1200" b="0">
+              <a:defRPr sz="1400" b="0">
                 <a:solidFill>
                   <a:srgbClr val="90A2BA"/>
                 </a:solidFill>
@@ -10225,6 +10421,10 @@
             <a:prstDash val="solid"/>
           </a:ln>
         </p:spPr>
+        <p:txBody xmlns:a="http://schemas.openxmlformats.org/drawingml/2006/main">
+          <a:bodyPr/>
+          <a:p/>
+        </p:txBody>
       </p:sp>
       <p:sp>
         <p:nvSpPr>
@@ -10254,7 +10454,7 @@
           <a:lstStyle xmlns:a="http://schemas.openxmlformats.org/drawingml/2006/main"/>
           <a:p xmlns:a="http://schemas.openxmlformats.org/drawingml/2006/main">
             <a:pPr algn="l">
-              <a:defRPr sz="975" b="1">
+              <a:defRPr sz="1250" b="1">
                 <a:solidFill>
                   <a:srgbClr val="FFB86B"/>
                 </a:solidFill>
@@ -10340,7 +10540,7 @@
           <a:lstStyle xmlns:a="http://schemas.openxmlformats.org/drawingml/2006/main"/>
           <a:p xmlns:a="http://schemas.openxmlformats.org/drawingml/2006/main">
             <a:pPr algn="l">
-              <a:defRPr sz="1200" b="0">
+              <a:defRPr sz="1400" b="0">
                 <a:solidFill>
                   <a:srgbClr val="90A2BA"/>
                 </a:solidFill>
@@ -10387,6 +10587,10 @@
             <a:prstDash val="solid"/>
           </a:ln>
         </p:spPr>
+        <p:txBody xmlns:a="http://schemas.openxmlformats.org/drawingml/2006/main">
+          <a:bodyPr/>
+          <a:p/>
+        </p:txBody>
       </p:sp>
       <p:sp>
         <p:nvSpPr>
@@ -10422,6 +10626,10 @@
             <a:prstDash val="solid"/>
           </a:ln>
         </p:spPr>
+        <p:txBody xmlns:a="http://schemas.openxmlformats.org/drawingml/2006/main">
+          <a:bodyPr/>
+          <a:p/>
+        </p:txBody>
       </p:sp>
       <p:sp>
         <p:nvSpPr>
@@ -10451,7 +10659,7 @@
           <a:lstStyle xmlns:a="http://schemas.openxmlformats.org/drawingml/2006/main"/>
           <a:p xmlns:a="http://schemas.openxmlformats.org/drawingml/2006/main">
             <a:pPr algn="l">
-              <a:defRPr sz="900" b="1">
+              <a:defRPr sz="1150" b="1">
                 <a:solidFill>
                   <a:srgbClr val="5EA7FF"/>
                 </a:solidFill>
@@ -10494,7 +10702,7 @@
           <a:lstStyle xmlns:a="http://schemas.openxmlformats.org/drawingml/2006/main"/>
           <a:p xmlns:a="http://schemas.openxmlformats.org/drawingml/2006/main">
             <a:pPr algn="l">
-              <a:defRPr sz="975" b="1">
+              <a:defRPr sz="1250" b="1">
                 <a:solidFill>
                   <a:srgbClr val="4DF0C0"/>
                 </a:solidFill>
@@ -10580,7 +10788,7 @@
           <a:lstStyle xmlns:a="http://schemas.openxmlformats.org/drawingml/2006/main"/>
           <a:p xmlns:a="http://schemas.openxmlformats.org/drawingml/2006/main">
             <a:pPr algn="l">
-              <a:defRPr sz="975" b="1">
+              <a:defRPr sz="1250" b="1">
                 <a:solidFill>
                   <a:srgbClr val="4DF0C0"/>
                 </a:solidFill>
@@ -10666,7 +10874,7 @@
           <a:lstStyle xmlns:a="http://schemas.openxmlformats.org/drawingml/2006/main"/>
           <a:p xmlns:a="http://schemas.openxmlformats.org/drawingml/2006/main">
             <a:pPr algn="l">
-              <a:defRPr sz="975" b="1">
+              <a:defRPr sz="1250" b="1">
                 <a:solidFill>
                   <a:srgbClr val="4DF0C0"/>
                 </a:solidFill>
@@ -10752,7 +10960,7 @@
           <a:lstStyle xmlns:a="http://schemas.openxmlformats.org/drawingml/2006/main"/>
           <a:p xmlns:a="http://schemas.openxmlformats.org/drawingml/2006/main">
             <a:pPr algn="l">
-              <a:defRPr sz="975" b="1">
+              <a:defRPr sz="1250" b="1">
                 <a:solidFill>
                   <a:srgbClr val="4DF0C0"/>
                 </a:solidFill>
@@ -10842,6 +11050,10 @@
             <a:prstDash val="solid"/>
           </a:ln>
         </p:spPr>
+        <p:txBody xmlns:a="http://schemas.openxmlformats.org/drawingml/2006/main">
+          <a:bodyPr/>
+          <a:p/>
+        </p:txBody>
       </p:sp>
       <p:sp>
         <p:nvSpPr>
@@ -10871,7 +11083,7 @@
           <a:lstStyle xmlns:a="http://schemas.openxmlformats.org/drawingml/2006/main"/>
           <a:p xmlns:a="http://schemas.openxmlformats.org/drawingml/2006/main">
             <a:pPr algn="l">
-              <a:defRPr sz="900" b="1">
+              <a:defRPr sz="1150" b="1">
                 <a:solidFill>
                   <a:srgbClr val="4DF0C0"/>
                 </a:solidFill>
@@ -11000,7 +11212,7 @@
           <a:lstStyle xmlns:a="http://schemas.openxmlformats.org/drawingml/2006/main"/>
           <a:p xmlns:a="http://schemas.openxmlformats.org/drawingml/2006/main">
             <a:pPr algn="l">
-              <a:defRPr sz="750" b="0">
+              <a:defRPr sz="925" b="0">
                 <a:solidFill>
                   <a:srgbClr val="607792"/>
                 </a:solidFill>
@@ -11043,7 +11255,7 @@
           <a:lstStyle xmlns:a="http://schemas.openxmlformats.org/drawingml/2006/main"/>
           <a:p xmlns:a="http://schemas.openxmlformats.org/drawingml/2006/main">
             <a:pPr algn="r">
-              <a:defRPr sz="825" b="1">
+              <a:defRPr sz="1050" b="1">
                 <a:solidFill>
                   <a:srgbClr val="4DF0C0"/>
                 </a:solidFill>

</xml_diff>